<commit_message>
fix(layout): reduce font/spacing in bullets & two_col to fix overflow on slides 12 & 16
bullets: main Pt(20)→Pt(17), sub Pt(17)→Pt(15), space_before 6→4pt, 2→1pt
two_col: main Pt(17)→Pt(15), sub Pt(15)→Pt(13), space_before 5→3pt, 2→1pt

Co-Authored-By: Claude Sonnet 4.6 <noreply@anthropic.com>
</commit_message>
<xml_diff>
--- a/output/network-card-csi-v5.1.pptx
+++ b/output/network-card-csi-v5.1.pptx
@@ -6558,11 +6558,11 @@
           <a:p>
             <a:pPr>
               <a:spcBef>
-                <a:spcPts val="600"/>
+                <a:spcPts val="400"/>
               </a:spcBef>
             </a:pPr>
             <a:r>
-              <a:rPr b="1" sz="2000">
+              <a:rPr b="1" sz="1700">
                 <a:solidFill>
                   <a:srgbClr val="505050"/>
                 </a:solidFill>
@@ -6573,11 +6573,11 @@
           <a:p>
             <a:pPr lvl="1">
               <a:spcBef>
-                <a:spcPts val="200"/>
+                <a:spcPts val="100"/>
               </a:spcBef>
             </a:pPr>
             <a:r>
-              <a:rPr sz="1700">
+              <a:rPr sz="1500">
                 <a:solidFill>
                   <a:srgbClr val="6B6B6B"/>
                 </a:solidFill>
@@ -6594,11 +6594,11 @@
           <a:p>
             <a:pPr>
               <a:spcBef>
-                <a:spcPts val="600"/>
+                <a:spcPts val="400"/>
               </a:spcBef>
             </a:pPr>
             <a:r>
-              <a:rPr b="1" sz="2000">
+              <a:rPr b="1" sz="1700">
                 <a:solidFill>
                   <a:srgbClr val="505050"/>
                 </a:solidFill>
@@ -6609,11 +6609,11 @@
           <a:p>
             <a:pPr lvl="1">
               <a:spcBef>
-                <a:spcPts val="200"/>
+                <a:spcPts val="100"/>
               </a:spcBef>
             </a:pPr>
             <a:r>
-              <a:rPr sz="1700">
+              <a:rPr sz="1500">
                 <a:solidFill>
                   <a:srgbClr val="6B6B6B"/>
                 </a:solidFill>
@@ -6624,11 +6624,11 @@
           <a:p>
             <a:pPr lvl="1">
               <a:spcBef>
-                <a:spcPts val="200"/>
+                <a:spcPts val="100"/>
               </a:spcBef>
             </a:pPr>
             <a:r>
-              <a:rPr sz="1700">
+              <a:rPr sz="1500">
                 <a:solidFill>
                   <a:srgbClr val="6B6B6B"/>
                 </a:solidFill>
@@ -6645,11 +6645,11 @@
           <a:p>
             <a:pPr>
               <a:spcBef>
-                <a:spcPts val="600"/>
+                <a:spcPts val="400"/>
               </a:spcBef>
             </a:pPr>
             <a:r>
-              <a:rPr b="1" sz="2000">
+              <a:rPr b="1" sz="1700">
                 <a:solidFill>
                   <a:srgbClr val="505050"/>
                 </a:solidFill>
@@ -6660,11 +6660,11 @@
           <a:p>
             <a:pPr lvl="1">
               <a:spcBef>
-                <a:spcPts val="200"/>
+                <a:spcPts val="100"/>
               </a:spcBef>
             </a:pPr>
             <a:r>
-              <a:rPr sz="1700">
+              <a:rPr sz="1500">
                 <a:solidFill>
                   <a:srgbClr val="6B6B6B"/>
                 </a:solidFill>
@@ -6681,11 +6681,11 @@
           <a:p>
             <a:pPr>
               <a:spcBef>
-                <a:spcPts val="600"/>
+                <a:spcPts val="400"/>
               </a:spcBef>
             </a:pPr>
             <a:r>
-              <a:rPr sz="2000">
+              <a:rPr sz="1700">
                 <a:solidFill>
                   <a:srgbClr val="1C1C1C"/>
                 </a:solidFill>
@@ -7143,11 +7143,11 @@
           <a:p>
             <a:pPr>
               <a:spcBef>
-                <a:spcPts val="600"/>
+                <a:spcPts val="400"/>
               </a:spcBef>
             </a:pPr>
             <a:r>
-              <a:rPr sz="2000">
+              <a:rPr sz="1700">
                 <a:solidFill>
                   <a:srgbClr val="1C1C1C"/>
                 </a:solidFill>
@@ -7158,11 +7158,11 @@
           <a:p>
             <a:pPr lvl="1">
               <a:spcBef>
-                <a:spcPts val="200"/>
+                <a:spcPts val="100"/>
               </a:spcBef>
             </a:pPr>
             <a:r>
-              <a:rPr sz="1700">
+              <a:rPr sz="1500">
                 <a:solidFill>
                   <a:srgbClr val="6B6B6B"/>
                 </a:solidFill>
@@ -7179,11 +7179,11 @@
           <a:p>
             <a:pPr>
               <a:spcBef>
-                <a:spcPts val="600"/>
+                <a:spcPts val="400"/>
               </a:spcBef>
             </a:pPr>
             <a:r>
-              <a:rPr sz="2000">
+              <a:rPr sz="1700">
                 <a:solidFill>
                   <a:srgbClr val="1C1C1C"/>
                 </a:solidFill>
@@ -7194,11 +7194,11 @@
           <a:p>
             <a:pPr>
               <a:spcBef>
-                <a:spcPts val="600"/>
+                <a:spcPts val="400"/>
               </a:spcBef>
             </a:pPr>
             <a:r>
-              <a:rPr b="1" sz="2000">
+              <a:rPr b="1" sz="1700">
                 <a:solidFill>
                   <a:srgbClr val="1C1C1C"/>
                 </a:solidFill>
@@ -7215,11 +7215,11 @@
           <a:p>
             <a:pPr>
               <a:spcBef>
-                <a:spcPts val="600"/>
+                <a:spcPts val="400"/>
               </a:spcBef>
             </a:pPr>
             <a:r>
-              <a:rPr b="1" sz="2000">
+              <a:rPr b="1" sz="1700">
                 <a:solidFill>
                   <a:srgbClr val="505050"/>
                 </a:solidFill>
@@ -7230,11 +7230,11 @@
           <a:p>
             <a:pPr lvl="1">
               <a:spcBef>
-                <a:spcPts val="200"/>
+                <a:spcPts val="100"/>
               </a:spcBef>
             </a:pPr>
             <a:r>
-              <a:rPr sz="1700">
+              <a:rPr sz="1500">
                 <a:solidFill>
                   <a:srgbClr val="6B6B6B"/>
                 </a:solidFill>
@@ -7245,11 +7245,11 @@
           <a:p>
             <a:pPr lvl="1">
               <a:spcBef>
-                <a:spcPts val="200"/>
+                <a:spcPts val="100"/>
               </a:spcBef>
             </a:pPr>
             <a:r>
-              <a:rPr sz="1700">
+              <a:rPr sz="1500">
                 <a:solidFill>
                   <a:srgbClr val="6B6B6B"/>
                 </a:solidFill>
@@ -7260,11 +7260,11 @@
           <a:p>
             <a:pPr lvl="1">
               <a:spcBef>
-                <a:spcPts val="200"/>
+                <a:spcPts val="100"/>
               </a:spcBef>
             </a:pPr>
             <a:r>
-              <a:rPr sz="1700">
+              <a:rPr sz="1500">
                 <a:solidFill>
                   <a:srgbClr val="6B6B6B"/>
                 </a:solidFill>
@@ -7281,11 +7281,11 @@
           <a:p>
             <a:pPr>
               <a:spcBef>
-                <a:spcPts val="600"/>
+                <a:spcPts val="400"/>
               </a:spcBef>
             </a:pPr>
             <a:r>
-              <a:rPr sz="2000">
+              <a:rPr sz="1700">
                 <a:solidFill>
                   <a:srgbClr val="1C1C1C"/>
                 </a:solidFill>
@@ -7770,11 +7770,11 @@
           <a:p>
             <a:pPr>
               <a:spcBef>
-                <a:spcPts val="500"/>
+                <a:spcPts val="300"/>
               </a:spcBef>
             </a:pPr>
             <a:r>
-              <a:rPr sz="1700">
+              <a:rPr sz="1500">
                 <a:solidFill>
                   <a:srgbClr val="1C1C1C"/>
                 </a:solidFill>
@@ -7785,11 +7785,11 @@
           <a:p>
             <a:pPr>
               <a:spcBef>
-                <a:spcPts val="500"/>
+                <a:spcPts val="300"/>
               </a:spcBef>
             </a:pPr>
             <a:r>
-              <a:rPr sz="1700">
+              <a:rPr sz="1500">
                 <a:solidFill>
                   <a:srgbClr val="1C1C1C"/>
                 </a:solidFill>
@@ -7800,11 +7800,11 @@
           <a:p>
             <a:pPr>
               <a:spcBef>
-                <a:spcPts val="500"/>
+                <a:spcPts val="300"/>
               </a:spcBef>
             </a:pPr>
             <a:r>
-              <a:rPr sz="1700">
+              <a:rPr sz="1500">
                 <a:solidFill>
                   <a:srgbClr val="1C1C1C"/>
                 </a:solidFill>
@@ -7815,11 +7815,11 @@
           <a:p>
             <a:pPr>
               <a:spcBef>
-                <a:spcPts val="200"/>
+                <a:spcPts val="100"/>
               </a:spcBef>
             </a:pPr>
             <a:r>
-              <a:rPr sz="1500">
+              <a:rPr sz="1300">
                 <a:solidFill>
                   <a:srgbClr val="6B6B6B"/>
                 </a:solidFill>
@@ -7830,11 +7830,11 @@
           <a:p>
             <a:pPr>
               <a:spcBef>
-                <a:spcPts val="200"/>
+                <a:spcPts val="100"/>
               </a:spcBef>
             </a:pPr>
             <a:r>
-              <a:rPr sz="1500">
+              <a:rPr sz="1300">
                 <a:solidFill>
                   <a:srgbClr val="6B6B6B"/>
                 </a:solidFill>
@@ -7845,11 +7845,11 @@
           <a:p>
             <a:pPr>
               <a:spcBef>
-                <a:spcPts val="500"/>
+                <a:spcPts val="300"/>
               </a:spcBef>
             </a:pPr>
             <a:r>
-              <a:rPr sz="1700">
+              <a:rPr sz="1500">
                 <a:solidFill>
                   <a:srgbClr val="1C1C1C"/>
                 </a:solidFill>
@@ -7860,11 +7860,11 @@
           <a:p>
             <a:pPr>
               <a:spcBef>
-                <a:spcPts val="500"/>
+                <a:spcPts val="300"/>
               </a:spcBef>
             </a:pPr>
             <a:r>
-              <a:rPr sz="1700">
+              <a:rPr sz="1500">
                 <a:solidFill>
                   <a:srgbClr val="1C1C1C"/>
                 </a:solidFill>
@@ -7933,11 +7933,11 @@
           <a:p>
             <a:pPr>
               <a:spcBef>
-                <a:spcPts val="500"/>
+                <a:spcPts val="300"/>
               </a:spcBef>
             </a:pPr>
             <a:r>
-              <a:rPr sz="1700" b="1">
+              <a:rPr sz="1500" b="1">
                 <a:solidFill>
                   <a:srgbClr val="1C1C1C"/>
                 </a:solidFill>
@@ -7948,11 +7948,11 @@
           <a:p>
             <a:pPr>
               <a:spcBef>
-                <a:spcPts val="200"/>
+                <a:spcPts val="100"/>
               </a:spcBef>
             </a:pPr>
             <a:r>
-              <a:rPr sz="1500">
+              <a:rPr sz="1300">
                 <a:solidFill>
                   <a:srgbClr val="6B6B6B"/>
                 </a:solidFill>
@@ -7969,11 +7969,11 @@
           <a:p>
             <a:pPr>
               <a:spcBef>
-                <a:spcPts val="500"/>
+                <a:spcPts val="300"/>
               </a:spcBef>
             </a:pPr>
             <a:r>
-              <a:rPr sz="1700">
+              <a:rPr sz="1500">
                 <a:solidFill>
                   <a:srgbClr val="1C1C1C"/>
                 </a:solidFill>
@@ -7984,11 +7984,11 @@
           <a:p>
             <a:pPr>
               <a:spcBef>
-                <a:spcPts val="200"/>
+                <a:spcPts val="100"/>
               </a:spcBef>
             </a:pPr>
             <a:r>
-              <a:rPr sz="1500">
+              <a:rPr sz="1300">
                 <a:solidFill>
                   <a:srgbClr val="6B6B6B"/>
                 </a:solidFill>
@@ -7999,11 +7999,11 @@
           <a:p>
             <a:pPr>
               <a:spcBef>
-                <a:spcPts val="200"/>
+                <a:spcPts val="100"/>
               </a:spcBef>
             </a:pPr>
             <a:r>
-              <a:rPr sz="1500">
+              <a:rPr sz="1300">
                 <a:solidFill>
                   <a:srgbClr val="6B6B6B"/>
                 </a:solidFill>
@@ -8014,11 +8014,11 @@
           <a:p>
             <a:pPr>
               <a:spcBef>
-                <a:spcPts val="200"/>
+                <a:spcPts val="100"/>
               </a:spcBef>
             </a:pPr>
             <a:r>
-              <a:rPr sz="1500">
+              <a:rPr sz="1300">
                 <a:solidFill>
                   <a:srgbClr val="6B6B6B"/>
                 </a:solidFill>
@@ -8029,11 +8029,11 @@
           <a:p>
             <a:pPr>
               <a:spcBef>
-                <a:spcPts val="200"/>
+                <a:spcPts val="100"/>
               </a:spcBef>
             </a:pPr>
             <a:r>
-              <a:rPr sz="1500">
+              <a:rPr sz="1300">
                 <a:solidFill>
                   <a:srgbClr val="6B6B6B"/>
                 </a:solidFill>
@@ -8050,11 +8050,11 @@
           <a:p>
             <a:pPr>
               <a:spcBef>
-                <a:spcPts val="500"/>
+                <a:spcPts val="300"/>
               </a:spcBef>
             </a:pPr>
             <a:r>
-              <a:rPr sz="1700">
+              <a:rPr sz="1500">
                 <a:solidFill>
                   <a:srgbClr val="1C1C1C"/>
                 </a:solidFill>
@@ -9827,11 +9827,11 @@
           <a:p>
             <a:pPr>
               <a:spcBef>
-                <a:spcPts val="500"/>
+                <a:spcPts val="300"/>
               </a:spcBef>
             </a:pPr>
             <a:r>
-              <a:rPr sz="1700">
+              <a:rPr sz="1500">
                 <a:solidFill>
                   <a:srgbClr val="1C1C1C"/>
                 </a:solidFill>
@@ -9842,11 +9842,11 @@
           <a:p>
             <a:pPr>
               <a:spcBef>
-                <a:spcPts val="500"/>
+                <a:spcPts val="300"/>
               </a:spcBef>
             </a:pPr>
             <a:r>
-              <a:rPr sz="1700">
+              <a:rPr sz="1500">
                 <a:solidFill>
                   <a:srgbClr val="1C1C1C"/>
                 </a:solidFill>
@@ -9857,11 +9857,11 @@
           <a:p>
             <a:pPr>
               <a:spcBef>
-                <a:spcPts val="500"/>
+                <a:spcPts val="300"/>
               </a:spcBef>
             </a:pPr>
             <a:r>
-              <a:rPr sz="1700">
+              <a:rPr sz="1500">
                 <a:solidFill>
                   <a:srgbClr val="1C1C1C"/>
                 </a:solidFill>
@@ -9878,11 +9878,11 @@
           <a:p>
             <a:pPr>
               <a:spcBef>
-                <a:spcPts val="500"/>
+                <a:spcPts val="300"/>
               </a:spcBef>
             </a:pPr>
             <a:r>
-              <a:rPr sz="1700">
+              <a:rPr sz="1500">
                 <a:solidFill>
                   <a:srgbClr val="1C1C1C"/>
                 </a:solidFill>
@@ -9893,11 +9893,11 @@
           <a:p>
             <a:pPr>
               <a:spcBef>
-                <a:spcPts val="200"/>
+                <a:spcPts val="100"/>
               </a:spcBef>
             </a:pPr>
             <a:r>
-              <a:rPr sz="1500">
+              <a:rPr sz="1300">
                 <a:solidFill>
                   <a:srgbClr val="6B6B6B"/>
                 </a:solidFill>
@@ -9908,11 +9908,11 @@
           <a:p>
             <a:pPr>
               <a:spcBef>
-                <a:spcPts val="200"/>
+                <a:spcPts val="100"/>
               </a:spcBef>
             </a:pPr>
             <a:r>
-              <a:rPr sz="1500">
+              <a:rPr sz="1300">
                 <a:solidFill>
                   <a:srgbClr val="6B6B6B"/>
                 </a:solidFill>
@@ -9923,11 +9923,11 @@
           <a:p>
             <a:pPr>
               <a:spcBef>
-                <a:spcPts val="200"/>
+                <a:spcPts val="100"/>
               </a:spcBef>
             </a:pPr>
             <a:r>
-              <a:rPr sz="1500">
+              <a:rPr sz="1300">
                 <a:solidFill>
                   <a:srgbClr val="6B6B6B"/>
                 </a:solidFill>
@@ -9944,11 +9944,11 @@
           <a:p>
             <a:pPr>
               <a:spcBef>
-                <a:spcPts val="500"/>
+                <a:spcPts val="300"/>
               </a:spcBef>
             </a:pPr>
             <a:r>
-              <a:rPr sz="1700">
+              <a:rPr sz="1500">
                 <a:solidFill>
                   <a:srgbClr val="1C1C1C"/>
                 </a:solidFill>
@@ -9959,11 +9959,11 @@
           <a:p>
             <a:pPr>
               <a:spcBef>
-                <a:spcPts val="200"/>
+                <a:spcPts val="100"/>
               </a:spcBef>
             </a:pPr>
             <a:r>
-              <a:rPr sz="1500">
+              <a:rPr sz="1300">
                 <a:solidFill>
                   <a:srgbClr val="6B6B6B"/>
                 </a:solidFill>
@@ -9974,11 +9974,11 @@
           <a:p>
             <a:pPr>
               <a:spcBef>
-                <a:spcPts val="200"/>
+                <a:spcPts val="100"/>
               </a:spcBef>
             </a:pPr>
             <a:r>
-              <a:rPr sz="1500">
+              <a:rPr sz="1300">
                 <a:solidFill>
                   <a:srgbClr val="6B6B6B"/>
                 </a:solidFill>
@@ -10047,11 +10047,11 @@
           <a:p>
             <a:pPr>
               <a:spcBef>
-                <a:spcPts val="500"/>
+                <a:spcPts val="300"/>
               </a:spcBef>
             </a:pPr>
             <a:r>
-              <a:rPr sz="1700" b="1">
+              <a:rPr sz="1500" b="1">
                 <a:solidFill>
                   <a:srgbClr val="1C1C1C"/>
                 </a:solidFill>
@@ -10062,11 +10062,11 @@
           <a:p>
             <a:pPr>
               <a:spcBef>
-                <a:spcPts val="500"/>
+                <a:spcPts val="300"/>
               </a:spcBef>
             </a:pPr>
             <a:r>
-              <a:rPr sz="1700" b="1">
+              <a:rPr sz="1500" b="1">
                 <a:solidFill>
                   <a:srgbClr val="1C1C1C"/>
                 </a:solidFill>
@@ -10077,11 +10077,11 @@
           <a:p>
             <a:pPr>
               <a:spcBef>
-                <a:spcPts val="500"/>
+                <a:spcPts val="300"/>
               </a:spcBef>
             </a:pPr>
             <a:r>
-              <a:rPr sz="1700" b="1">
+              <a:rPr sz="1500" b="1">
                 <a:solidFill>
                   <a:srgbClr val="1C1C1C"/>
                 </a:solidFill>
@@ -10092,11 +10092,11 @@
           <a:p>
             <a:pPr>
               <a:spcBef>
-                <a:spcPts val="500"/>
+                <a:spcPts val="300"/>
               </a:spcBef>
             </a:pPr>
             <a:r>
-              <a:rPr sz="1700" b="1">
+              <a:rPr sz="1500" b="1">
                 <a:solidFill>
                   <a:srgbClr val="1C1C1C"/>
                 </a:solidFill>
@@ -10113,11 +10113,11 @@
           <a:p>
             <a:pPr>
               <a:spcBef>
-                <a:spcPts val="500"/>
+                <a:spcPts val="300"/>
               </a:spcBef>
             </a:pPr>
             <a:r>
-              <a:rPr sz="1700">
+              <a:rPr sz="1500">
                 <a:solidFill>
                   <a:srgbClr val="1C1C1C"/>
                 </a:solidFill>
@@ -10128,11 +10128,11 @@
           <a:p>
             <a:pPr>
               <a:spcBef>
-                <a:spcPts val="200"/>
+                <a:spcPts val="100"/>
               </a:spcBef>
             </a:pPr>
             <a:r>
-              <a:rPr sz="1500">
+              <a:rPr sz="1300">
                 <a:solidFill>
                   <a:srgbClr val="6B6B6B"/>
                 </a:solidFill>
@@ -10143,11 +10143,11 @@
           <a:p>
             <a:pPr>
               <a:spcBef>
-                <a:spcPts val="200"/>
+                <a:spcPts val="100"/>
               </a:spcBef>
             </a:pPr>
             <a:r>
-              <a:rPr sz="1500">
+              <a:rPr sz="1300">
                 <a:solidFill>
                   <a:srgbClr val="6B6B6B"/>
                 </a:solidFill>
@@ -13958,11 +13958,11 @@
           <a:p>
             <a:pPr>
               <a:spcBef>
-                <a:spcPts val="600"/>
+                <a:spcPts val="400"/>
               </a:spcBef>
             </a:pPr>
             <a:r>
-              <a:rPr sz="2000">
+              <a:rPr sz="1700">
                 <a:solidFill>
                   <a:srgbClr val="1C1C1C"/>
                 </a:solidFill>
@@ -13973,11 +13973,11 @@
           <a:p>
             <a:pPr lvl="1">
               <a:spcBef>
-                <a:spcPts val="200"/>
+                <a:spcPts val="100"/>
               </a:spcBef>
             </a:pPr>
             <a:r>
-              <a:rPr sz="1700">
+              <a:rPr sz="1500">
                 <a:solidFill>
                   <a:srgbClr val="6B6B6B"/>
                 </a:solidFill>
@@ -13988,11 +13988,11 @@
           <a:p>
             <a:pPr lvl="1">
               <a:spcBef>
-                <a:spcPts val="200"/>
+                <a:spcPts val="100"/>
               </a:spcBef>
             </a:pPr>
             <a:r>
-              <a:rPr sz="1700">
+              <a:rPr sz="1500">
                 <a:solidFill>
                   <a:srgbClr val="6B6B6B"/>
                 </a:solidFill>
@@ -14003,11 +14003,11 @@
           <a:p>
             <a:pPr lvl="1">
               <a:spcBef>
-                <a:spcPts val="200"/>
+                <a:spcPts val="100"/>
               </a:spcBef>
             </a:pPr>
             <a:r>
-              <a:rPr sz="1700">
+              <a:rPr sz="1500">
                 <a:solidFill>
                   <a:srgbClr val="6B6B6B"/>
                 </a:solidFill>
@@ -14018,11 +14018,11 @@
           <a:p>
             <a:pPr>
               <a:spcBef>
-                <a:spcPts val="600"/>
+                <a:spcPts val="400"/>
               </a:spcBef>
             </a:pPr>
             <a:r>
-              <a:rPr sz="2000">
+              <a:rPr sz="1700">
                 <a:solidFill>
                   <a:srgbClr val="1C1C1C"/>
                 </a:solidFill>
@@ -14033,11 +14033,11 @@
           <a:p>
             <a:pPr lvl="1">
               <a:spcBef>
-                <a:spcPts val="200"/>
+                <a:spcPts val="100"/>
               </a:spcBef>
             </a:pPr>
             <a:r>
-              <a:rPr sz="1700">
+              <a:rPr sz="1500">
                 <a:solidFill>
                   <a:srgbClr val="6B6B6B"/>
                 </a:solidFill>
@@ -14048,11 +14048,11 @@
           <a:p>
             <a:pPr lvl="1">
               <a:spcBef>
-                <a:spcPts val="200"/>
+                <a:spcPts val="100"/>
               </a:spcBef>
             </a:pPr>
             <a:r>
-              <a:rPr sz="1700">
+              <a:rPr sz="1500">
                 <a:solidFill>
                   <a:srgbClr val="6B6B6B"/>
                 </a:solidFill>
@@ -14063,11 +14063,11 @@
           <a:p>
             <a:pPr>
               <a:spcBef>
-                <a:spcPts val="600"/>
+                <a:spcPts val="400"/>
               </a:spcBef>
             </a:pPr>
             <a:r>
-              <a:rPr sz="2000">
+              <a:rPr sz="1700">
                 <a:solidFill>
                   <a:srgbClr val="1C1C1C"/>
                 </a:solidFill>
@@ -14078,11 +14078,11 @@
           <a:p>
             <a:pPr lvl="1">
               <a:spcBef>
-                <a:spcPts val="200"/>
+                <a:spcPts val="100"/>
               </a:spcBef>
             </a:pPr>
             <a:r>
-              <a:rPr sz="1700">
+              <a:rPr sz="1500">
                 <a:solidFill>
                   <a:srgbClr val="6B6B6B"/>
                 </a:solidFill>
@@ -14093,11 +14093,11 @@
           <a:p>
             <a:pPr lvl="1">
               <a:spcBef>
-                <a:spcPts val="200"/>
+                <a:spcPts val="100"/>
               </a:spcBef>
             </a:pPr>
             <a:r>
-              <a:rPr sz="1700">
+              <a:rPr sz="1500">
                 <a:solidFill>
                   <a:srgbClr val="6B6B6B"/>
                 </a:solidFill>
@@ -14108,11 +14108,11 @@
           <a:p>
             <a:pPr>
               <a:spcBef>
-                <a:spcPts val="600"/>
+                <a:spcPts val="400"/>
               </a:spcBef>
             </a:pPr>
             <a:r>
-              <a:rPr sz="2000">
+              <a:rPr sz="1700">
                 <a:solidFill>
                   <a:srgbClr val="1C1C1C"/>
                 </a:solidFill>
@@ -15753,11 +15753,11 @@
           <a:p>
             <a:pPr>
               <a:spcBef>
-                <a:spcPts val="600"/>
+                <a:spcPts val="400"/>
               </a:spcBef>
             </a:pPr>
             <a:r>
-              <a:rPr b="1" sz="2000">
+              <a:rPr b="1" sz="1700">
                 <a:solidFill>
                   <a:srgbClr val="505050"/>
                 </a:solidFill>
@@ -15768,11 +15768,11 @@
           <a:p>
             <a:pPr lvl="1">
               <a:spcBef>
-                <a:spcPts val="200"/>
+                <a:spcPts val="100"/>
               </a:spcBef>
             </a:pPr>
             <a:r>
-              <a:rPr sz="1700">
+              <a:rPr sz="1500">
                 <a:solidFill>
                   <a:srgbClr val="6B6B6B"/>
                 </a:solidFill>
@@ -15789,11 +15789,11 @@
           <a:p>
             <a:pPr>
               <a:spcBef>
-                <a:spcPts val="600"/>
+                <a:spcPts val="400"/>
               </a:spcBef>
             </a:pPr>
             <a:r>
-              <a:rPr b="1" sz="2000">
+              <a:rPr b="1" sz="1700">
                 <a:solidFill>
                   <a:srgbClr val="505050"/>
                 </a:solidFill>
@@ -15804,11 +15804,11 @@
           <a:p>
             <a:pPr lvl="1">
               <a:spcBef>
-                <a:spcPts val="200"/>
+                <a:spcPts val="100"/>
               </a:spcBef>
             </a:pPr>
             <a:r>
-              <a:rPr sz="1700">
+              <a:rPr sz="1500">
                 <a:solidFill>
                   <a:srgbClr val="6B6B6B"/>
                 </a:solidFill>
@@ -15819,11 +15819,11 @@
           <a:p>
             <a:pPr lvl="1">
               <a:spcBef>
-                <a:spcPts val="200"/>
+                <a:spcPts val="100"/>
               </a:spcBef>
             </a:pPr>
             <a:r>
-              <a:rPr sz="1700">
+              <a:rPr sz="1500">
                 <a:solidFill>
                   <a:srgbClr val="6B6B6B"/>
                 </a:solidFill>
@@ -15840,11 +15840,11 @@
           <a:p>
             <a:pPr>
               <a:spcBef>
-                <a:spcPts val="600"/>
+                <a:spcPts val="400"/>
               </a:spcBef>
             </a:pPr>
             <a:r>
-              <a:rPr b="1" sz="2000">
+              <a:rPr b="1" sz="1700">
                 <a:solidFill>
                   <a:srgbClr val="505050"/>
                 </a:solidFill>
@@ -15855,11 +15855,11 @@
           <a:p>
             <a:pPr lvl="1">
               <a:spcBef>
-                <a:spcPts val="200"/>
+                <a:spcPts val="100"/>
               </a:spcBef>
             </a:pPr>
             <a:r>
-              <a:rPr sz="1700">
+              <a:rPr sz="1500">
                 <a:solidFill>
                   <a:srgbClr val="6B6B6B"/>
                 </a:solidFill>
@@ -15870,11 +15870,11 @@
           <a:p>
             <a:pPr lvl="1">
               <a:spcBef>
-                <a:spcPts val="200"/>
+                <a:spcPts val="100"/>
               </a:spcBef>
             </a:pPr>
             <a:r>
-              <a:rPr sz="1700">
+              <a:rPr sz="1500">
                 <a:solidFill>
                   <a:srgbClr val="6B6B6B"/>
                 </a:solidFill>
@@ -15885,11 +15885,11 @@
           <a:p>
             <a:pPr lvl="1">
               <a:spcBef>
-                <a:spcPts val="200"/>
+                <a:spcPts val="100"/>
               </a:spcBef>
             </a:pPr>
             <a:r>
-              <a:rPr sz="1700">
+              <a:rPr sz="1500">
                 <a:solidFill>
                   <a:srgbClr val="6B6B6B"/>
                 </a:solidFill>
@@ -18009,11 +18009,11 @@
           <a:p>
             <a:pPr>
               <a:spcBef>
-                <a:spcPts val="500"/>
+                <a:spcPts val="300"/>
               </a:spcBef>
             </a:pPr>
             <a:r>
-              <a:rPr sz="1700">
+              <a:rPr sz="1500">
                 <a:solidFill>
                   <a:srgbClr val="1C1C1C"/>
                 </a:solidFill>
@@ -18024,11 +18024,11 @@
           <a:p>
             <a:pPr>
               <a:spcBef>
-                <a:spcPts val="500"/>
+                <a:spcPts val="300"/>
               </a:spcBef>
             </a:pPr>
             <a:r>
-              <a:rPr sz="1700">
+              <a:rPr sz="1500">
                 <a:solidFill>
                   <a:srgbClr val="1C1C1C"/>
                 </a:solidFill>
@@ -18039,11 +18039,11 @@
           <a:p>
             <a:pPr>
               <a:spcBef>
-                <a:spcPts val="500"/>
+                <a:spcPts val="300"/>
               </a:spcBef>
             </a:pPr>
             <a:r>
-              <a:rPr sz="1700">
+              <a:rPr sz="1500">
                 <a:solidFill>
                   <a:srgbClr val="1C1C1C"/>
                 </a:solidFill>
@@ -18054,11 +18054,11 @@
           <a:p>
             <a:pPr>
               <a:spcBef>
-                <a:spcPts val="500"/>
+                <a:spcPts val="300"/>
               </a:spcBef>
             </a:pPr>
             <a:r>
-              <a:rPr sz="1700">
+              <a:rPr sz="1500">
                 <a:solidFill>
                   <a:srgbClr val="1C1C1C"/>
                 </a:solidFill>
@@ -18127,11 +18127,11 @@
           <a:p>
             <a:pPr>
               <a:spcBef>
-                <a:spcPts val="500"/>
+                <a:spcPts val="300"/>
               </a:spcBef>
             </a:pPr>
             <a:r>
-              <a:rPr sz="1700">
+              <a:rPr sz="1500">
                 <a:solidFill>
                   <a:srgbClr val="1C1C1C"/>
                 </a:solidFill>
@@ -18148,11 +18148,11 @@
           <a:p>
             <a:pPr>
               <a:spcBef>
-                <a:spcPts val="500"/>
+                <a:spcPts val="300"/>
               </a:spcBef>
             </a:pPr>
             <a:r>
-              <a:rPr sz="1700" b="1">
+              <a:rPr sz="1500" b="1">
                 <a:solidFill>
                   <a:srgbClr val="1C1C1C"/>
                 </a:solidFill>
@@ -18163,11 +18163,11 @@
           <a:p>
             <a:pPr>
               <a:spcBef>
-                <a:spcPts val="200"/>
+                <a:spcPts val="100"/>
               </a:spcBef>
             </a:pPr>
             <a:r>
-              <a:rPr sz="1500">
+              <a:rPr sz="1300">
                 <a:solidFill>
                   <a:srgbClr val="6B6B6B"/>
                 </a:solidFill>
@@ -18178,11 +18178,11 @@
           <a:p>
             <a:pPr>
               <a:spcBef>
-                <a:spcPts val="200"/>
+                <a:spcPts val="100"/>
               </a:spcBef>
             </a:pPr>
             <a:r>
-              <a:rPr sz="1500">
+              <a:rPr sz="1300">
                 <a:solidFill>
                   <a:srgbClr val="6B6B6B"/>
                 </a:solidFill>
@@ -18193,11 +18193,11 @@
           <a:p>
             <a:pPr>
               <a:spcBef>
-                <a:spcPts val="200"/>
+                <a:spcPts val="100"/>
               </a:spcBef>
             </a:pPr>
             <a:r>
-              <a:rPr sz="1500">
+              <a:rPr sz="1300">
                 <a:solidFill>
                   <a:srgbClr val="6B6B6B"/>
                 </a:solidFill>
@@ -18214,11 +18214,11 @@
           <a:p>
             <a:pPr>
               <a:spcBef>
-                <a:spcPts val="500"/>
+                <a:spcPts val="300"/>
               </a:spcBef>
             </a:pPr>
             <a:r>
-              <a:rPr sz="1700">
+              <a:rPr sz="1500">
                 <a:solidFill>
                   <a:srgbClr val="1C1C1C"/>
                 </a:solidFill>
@@ -21521,11 +21521,11 @@
           <a:p>
             <a:pPr>
               <a:spcBef>
-                <a:spcPts val="500"/>
+                <a:spcPts val="300"/>
               </a:spcBef>
             </a:pPr>
             <a:r>
-              <a:rPr sz="1700">
+              <a:rPr sz="1500">
                 <a:solidFill>
                   <a:srgbClr val="1C1C1C"/>
                 </a:solidFill>
@@ -21536,11 +21536,11 @@
           <a:p>
             <a:pPr>
               <a:spcBef>
-                <a:spcPts val="500"/>
+                <a:spcPts val="300"/>
               </a:spcBef>
             </a:pPr>
             <a:r>
-              <a:rPr sz="1700">
+              <a:rPr sz="1500">
                 <a:solidFill>
                   <a:srgbClr val="1C1C1C"/>
                 </a:solidFill>
@@ -21551,11 +21551,11 @@
           <a:p>
             <a:pPr>
               <a:spcBef>
-                <a:spcPts val="500"/>
+                <a:spcPts val="300"/>
               </a:spcBef>
             </a:pPr>
             <a:r>
-              <a:rPr sz="1700">
+              <a:rPr sz="1500">
                 <a:solidFill>
                   <a:srgbClr val="1C1C1C"/>
                 </a:solidFill>
@@ -21566,11 +21566,11 @@
           <a:p>
             <a:pPr>
               <a:spcBef>
-                <a:spcPts val="500"/>
+                <a:spcPts val="300"/>
               </a:spcBef>
             </a:pPr>
             <a:r>
-              <a:rPr sz="1700">
+              <a:rPr sz="1500">
                 <a:solidFill>
                   <a:srgbClr val="1C1C1C"/>
                 </a:solidFill>
@@ -21581,11 +21581,11 @@
           <a:p>
             <a:pPr>
               <a:spcBef>
-                <a:spcPts val="500"/>
+                <a:spcPts val="300"/>
               </a:spcBef>
             </a:pPr>
             <a:r>
-              <a:rPr sz="1700">
+              <a:rPr sz="1500">
                 <a:solidFill>
                   <a:srgbClr val="1C1C1C"/>
                 </a:solidFill>
@@ -21654,11 +21654,11 @@
           <a:p>
             <a:pPr>
               <a:spcBef>
-                <a:spcPts val="500"/>
+                <a:spcPts val="300"/>
               </a:spcBef>
             </a:pPr>
             <a:r>
-              <a:rPr sz="1700">
+              <a:rPr sz="1500">
                 <a:solidFill>
                   <a:srgbClr val="1C1C1C"/>
                 </a:solidFill>
@@ -21669,11 +21669,11 @@
           <a:p>
             <a:pPr>
               <a:spcBef>
-                <a:spcPts val="500"/>
+                <a:spcPts val="300"/>
               </a:spcBef>
             </a:pPr>
             <a:r>
-              <a:rPr sz="1700">
+              <a:rPr sz="1500">
                 <a:solidFill>
                   <a:srgbClr val="1C1C1C"/>
                 </a:solidFill>
@@ -21684,11 +21684,11 @@
           <a:p>
             <a:pPr>
               <a:spcBef>
-                <a:spcPts val="500"/>
+                <a:spcPts val="300"/>
               </a:spcBef>
             </a:pPr>
             <a:r>
-              <a:rPr sz="1700">
+              <a:rPr sz="1500">
                 <a:solidFill>
                   <a:srgbClr val="1C1C1C"/>
                 </a:solidFill>
@@ -21699,11 +21699,11 @@
           <a:p>
             <a:pPr>
               <a:spcBef>
-                <a:spcPts val="500"/>
+                <a:spcPts val="300"/>
               </a:spcBef>
             </a:pPr>
             <a:r>
-              <a:rPr sz="1700">
+              <a:rPr sz="1500">
                 <a:solidFill>
                   <a:srgbClr val="1C1C1C"/>
                 </a:solidFill>
@@ -21720,11 +21720,11 @@
           <a:p>
             <a:pPr>
               <a:spcBef>
-                <a:spcPts val="500"/>
+                <a:spcPts val="300"/>
               </a:spcBef>
             </a:pPr>
             <a:r>
-              <a:rPr sz="1700" b="1">
+              <a:rPr sz="1500" b="1">
                 <a:solidFill>
                   <a:srgbClr val="1C1C1C"/>
                 </a:solidFill>
@@ -21735,11 +21735,11 @@
           <a:p>
             <a:pPr>
               <a:spcBef>
-                <a:spcPts val="200"/>
+                <a:spcPts val="100"/>
               </a:spcBef>
             </a:pPr>
             <a:r>
-              <a:rPr sz="1500">
+              <a:rPr sz="1300">
                 <a:solidFill>
                   <a:srgbClr val="6B6B6B"/>
                 </a:solidFill>

</xml_diff>